<commit_message>
Update RAGNAROK team members: full names and emails
</commit_message>
<xml_diff>
--- a/RAGNAROK/OnChainIn_Pitch_RAGNAROK.pptx
+++ b/RAGNAROK/OnChainIn_Pitch_RAGNAROK.pptx
@@ -3118,8 +3118,8 @@
         </p:nvSpPr>
         <p:spPr>
           <a:xfrm>
-            <a:off x="640080" y="457200"/>
-            <a:ext cx="7772400" cy="411480"/>
+            <a:off x="640080" y="411480"/>
+            <a:ext cx="7772400" cy="365760"/>
           </a:xfrm>
           <a:prstGeom prst="rect">
             <a:avLst/>
@@ -3135,7 +3135,7 @@
               <a:buNone/>
             </a:pPr>
             <a:r>
-              <a:rPr lang="en-US" sz="2800" b="1" dirty="0">
+              <a:rPr lang="en-US" sz="2600" b="1" dirty="0">
                 <a:solidFill>
                   <a:srgbClr val="FFFFFF"/>
                 </a:solidFill>
@@ -3145,7 +3145,7 @@
               </a:rPr>
               <a:t>Try it live</a:t>
             </a:r>
-            <a:endParaRPr lang="en-US" sz="2800" dirty="0"/>
+            <a:endParaRPr lang="en-US" sz="2600" dirty="0"/>
           </a:p>
         </p:txBody>
       </p:sp>
@@ -3157,8 +3157,8 @@
         </p:nvSpPr>
         <p:spPr>
           <a:xfrm>
-            <a:off x="640080" y="1005840"/>
-            <a:ext cx="7772400" cy="365760"/>
+            <a:off x="640080" y="868680"/>
+            <a:ext cx="7772400" cy="320040"/>
           </a:xfrm>
           <a:prstGeom prst="rect">
             <a:avLst/>
@@ -3174,7 +3174,7 @@
               <a:buNone/>
             </a:pPr>
             <a:r>
-              <a:rPr lang="en-US" sz="2000" dirty="0">
+              <a:rPr lang="en-US" sz="1800" dirty="0">
                 <a:solidFill>
                   <a:srgbClr val="22D3EE"/>
                 </a:solidFill>
@@ -3184,7 +3184,7 @@
               </a:rPr>
               <a:t>https://onchainin.vercel.app</a:t>
             </a:r>
-            <a:endParaRPr lang="en-US" sz="2000" dirty="0"/>
+            <a:endParaRPr lang="en-US" sz="1800" dirty="0"/>
           </a:p>
         </p:txBody>
       </p:sp>
@@ -3196,8 +3196,8 @@
         </p:nvSpPr>
         <p:spPr>
           <a:xfrm>
-            <a:off x="640080" y="1554480"/>
-            <a:ext cx="7772400" cy="1280160"/>
+            <a:off x="640080" y="1325880"/>
+            <a:ext cx="7772400" cy="1051560"/>
           </a:xfrm>
           <a:prstGeom prst="rect">
             <a:avLst/>
@@ -3214,7 +3214,7 @@
               <a:buChar char="•"/>
             </a:pPr>
             <a:r>
-              <a:rPr lang="en-US" sz="1500" dirty="0">
+              <a:rPr lang="en-US" sz="1400" dirty="0">
                 <a:solidFill>
                   <a:srgbClr val="A8C5FF"/>
                 </a:solidFill>
@@ -3224,7 +3224,7 @@
               </a:rPr>
               <a:t>Sign up as organizer or participant</a:t>
             </a:r>
-            <a:endParaRPr lang="en-US" sz="1500" dirty="0"/>
+            <a:endParaRPr lang="en-US" sz="1400" dirty="0"/>
           </a:p>
           <a:p>
             <a:pPr marL="342900" indent="-342900">
@@ -3232,7 +3232,7 @@
               <a:buChar char="•"/>
             </a:pPr>
             <a:r>
-              <a:rPr lang="en-US" sz="1500" dirty="0">
+              <a:rPr lang="en-US" sz="1400" dirty="0">
                 <a:solidFill>
                   <a:srgbClr val="A8C5FF"/>
                 </a:solidFill>
@@ -3242,7 +3242,7 @@
               </a:rPr>
               <a:t>Create event, approve, wallet check-in on Preprod</a:t>
             </a:r>
-            <a:endParaRPr lang="en-US" sz="1500" dirty="0"/>
+            <a:endParaRPr lang="en-US" sz="1400" dirty="0"/>
           </a:p>
           <a:p>
             <a:pPr marL="342900" indent="-342900">
@@ -3250,7 +3250,7 @@
               <a:buChar char="•"/>
             </a:pPr>
             <a:r>
-              <a:rPr lang="en-US" sz="1500" dirty="0">
+              <a:rPr lang="en-US" sz="1400" dirty="0">
                 <a:solidFill>
                   <a:srgbClr val="A8C5FF"/>
                 </a:solidFill>
@@ -3260,42 +3260,20 @@
               </a:rPr>
               <a:t>Issue certificate, open verify with Blockfrost</a:t>
             </a:r>
-            <a:endParaRPr lang="en-US" sz="1500" dirty="0"/>
-          </a:p>
-        </p:txBody>
-      </p:sp>
-      <p:sp>
-        <p:nvSpPr>
-          <p:cNvPr id="7" name="Shape 5"/>
-          <p:cNvSpPr/>
-          <p:nvPr/>
-        </p:nvSpPr>
-        <p:spPr>
-          <a:xfrm>
-            <a:off x="640080" y="3108960"/>
-            <a:ext cx="7863840" cy="1463040"/>
-          </a:xfrm>
-          <a:prstGeom prst="roundRect">
-            <a:avLst>
-              <a:gd name="adj" fmla="val 6250"/>
-            </a:avLst>
-          </a:prstGeom>
-          <a:solidFill>
-            <a:srgbClr val="121A2B"/>
-          </a:solidFill>
-          <a:ln/>
-        </p:spPr>
-      </p:sp>
-      <p:sp>
-        <p:nvSpPr>
-          <p:cNvPr id="8" name="Text 6"/>
-          <p:cNvSpPr/>
-          <p:nvPr/>
-        </p:nvSpPr>
-        <p:spPr>
-          <a:xfrm>
-            <a:off x="868680" y="3291840"/>
-            <a:ext cx="7315200" cy="320040"/>
+            <a:endParaRPr lang="en-US" sz="1400" dirty="0"/>
+          </a:p>
+        </p:txBody>
+      </p:sp>
+      <p:sp>
+        <p:nvSpPr>
+          <p:cNvPr id="7" name="Text 5"/>
+          <p:cNvSpPr/>
+          <p:nvPr/>
+        </p:nvSpPr>
+        <p:spPr>
+          <a:xfrm>
+            <a:off x="640080" y="2514600"/>
+            <a:ext cx="7772400" cy="320040"/>
           </a:xfrm>
           <a:prstGeom prst="rect">
             <a:avLst/>
@@ -3327,14 +3305,36 @@
       </p:sp>
       <p:sp>
         <p:nvSpPr>
+          <p:cNvPr id="8" name="Shape 6"/>
+          <p:cNvSpPr/>
+          <p:nvPr/>
+        </p:nvSpPr>
+        <p:spPr>
+          <a:xfrm>
+            <a:off x="640080" y="2971800"/>
+            <a:ext cx="3794760" cy="1691640"/>
+          </a:xfrm>
+          <a:prstGeom prst="roundRect">
+            <a:avLst>
+              <a:gd name="adj" fmla="val 5405"/>
+            </a:avLst>
+          </a:prstGeom>
+          <a:solidFill>
+            <a:srgbClr val="121A2B"/>
+          </a:solidFill>
+          <a:ln/>
+        </p:spPr>
+      </p:sp>
+      <p:sp>
+        <p:nvSpPr>
           <p:cNvPr id="9" name="Text 7"/>
           <p:cNvSpPr/>
           <p:nvPr/>
         </p:nvSpPr>
         <p:spPr>
           <a:xfrm>
-            <a:off x="868680" y="3703320"/>
-            <a:ext cx="7315200" cy="274320"/>
+            <a:off x="868680" y="3154680"/>
+            <a:ext cx="3383280" cy="320040"/>
           </a:xfrm>
           <a:prstGeom prst="rect">
             <a:avLst/>
@@ -3350,7 +3350,46 @@
               <a:buNone/>
             </a:pPr>
             <a:r>
-              <a:rPr lang="en-US" sz="1400" dirty="0">
+              <a:rPr lang="en-US" sz="1600" b="1" dirty="0">
+                <a:solidFill>
+                  <a:srgbClr val="FFFFFF"/>
+                </a:solidFill>
+                <a:latin typeface="Arial" pitchFamily="34" charset="0"/>
+                <a:ea typeface="Arial" pitchFamily="34" charset="-122"/>
+                <a:cs typeface="Arial" pitchFamily="34" charset="-120"/>
+              </a:rPr>
+              <a:t>Anshul Nautiyal</a:t>
+            </a:r>
+            <a:endParaRPr lang="en-US" sz="1600" dirty="0"/>
+          </a:p>
+        </p:txBody>
+      </p:sp>
+      <p:sp>
+        <p:nvSpPr>
+          <p:cNvPr id="10" name="Text 8"/>
+          <p:cNvSpPr/>
+          <p:nvPr/>
+        </p:nvSpPr>
+        <p:spPr>
+          <a:xfrm>
+            <a:off x="868680" y="3566160"/>
+            <a:ext cx="3383280" cy="274320"/>
+          </a:xfrm>
+          <a:prstGeom prst="rect">
+            <a:avLst/>
+          </a:prstGeom>
+          <a:noFill/>
+          <a:ln/>
+        </p:spPr>
+        <p:txBody>
+          <a:bodyPr wrap="square" lIns="0" tIns="0" rIns="0" bIns="0" rtlCol="0" anchor="ctr"/>
+          <a:lstStyle/>
+          <a:p>
+            <a:pPr indent="0" marL="0">
+              <a:buNone/>
+            </a:pPr>
+            <a:r>
+              <a:rPr lang="en-US" sz="1300" dirty="0">
                 <a:solidFill>
                   <a:srgbClr val="A8C5FF"/>
                 </a:solidFill>
@@ -3358,22 +3397,22 @@
                 <a:ea typeface="Calibri" pitchFamily="34" charset="-122"/>
                 <a:cs typeface="Calibri" pitchFamily="34" charset="-120"/>
               </a:rPr>
-              <a:t>GitHub: ANSHUL-REAL  |  SOURABREDDY394</a:t>
-            </a:r>
-            <a:endParaRPr lang="en-US" sz="1400" dirty="0"/>
-          </a:p>
-        </p:txBody>
-      </p:sp>
-      <p:sp>
-        <p:nvSpPr>
-          <p:cNvPr id="10" name="Text 8"/>
-          <p:cNvSpPr/>
-          <p:nvPr/>
-        </p:nvSpPr>
-        <p:spPr>
-          <a:xfrm>
-            <a:off x="868680" y="4069080"/>
-            <a:ext cx="7315200" cy="274320"/>
+              <a:t>GitHub: ANSHUL-REAL</a:t>
+            </a:r>
+            <a:endParaRPr lang="en-US" sz="1300" dirty="0"/>
+          </a:p>
+        </p:txBody>
+      </p:sp>
+      <p:sp>
+        <p:nvSpPr>
+          <p:cNvPr id="11" name="Text 9"/>
+          <p:cNvSpPr/>
+          <p:nvPr/>
+        </p:nvSpPr>
+        <p:spPr>
+          <a:xfrm>
+            <a:off x="868680" y="3931920"/>
+            <a:ext cx="3383280" cy="320040"/>
           </a:xfrm>
           <a:prstGeom prst="rect">
             <a:avLst/>
@@ -3389,7 +3428,7 @@
               <a:buNone/>
             </a:pPr>
             <a:r>
-              <a:rPr lang="en-US" sz="1300" dirty="0">
+              <a:rPr lang="en-US" sz="1200" dirty="0">
                 <a:solidFill>
                   <a:srgbClr val="94A3B8"/>
                 </a:solidFill>
@@ -3397,9 +3436,148 @@
                 <a:ea typeface="Calibri" pitchFamily="34" charset="-122"/>
                 <a:cs typeface="Calibri" pitchFamily="34" charset="-120"/>
               </a:rPr>
-              <a:t>editzera07@gmail.com  |  Made with love for IndiaCodex'26</a:t>
+              <a:t>anshulnautiyal0512@gmail.com</a:t>
+            </a:r>
+            <a:endParaRPr lang="en-US" sz="1200" dirty="0"/>
+          </a:p>
+        </p:txBody>
+      </p:sp>
+      <p:sp>
+        <p:nvSpPr>
+          <p:cNvPr id="12" name="Shape 10"/>
+          <p:cNvSpPr/>
+          <p:nvPr/>
+        </p:nvSpPr>
+        <p:spPr>
+          <a:xfrm>
+            <a:off x="4709160" y="2971800"/>
+            <a:ext cx="3794760" cy="1691640"/>
+          </a:xfrm>
+          <a:prstGeom prst="roundRect">
+            <a:avLst>
+              <a:gd name="adj" fmla="val 5405"/>
+            </a:avLst>
+          </a:prstGeom>
+          <a:solidFill>
+            <a:srgbClr val="121A2B"/>
+          </a:solidFill>
+          <a:ln/>
+        </p:spPr>
+      </p:sp>
+      <p:sp>
+        <p:nvSpPr>
+          <p:cNvPr id="13" name="Text 11"/>
+          <p:cNvSpPr/>
+          <p:nvPr/>
+        </p:nvSpPr>
+        <p:spPr>
+          <a:xfrm>
+            <a:off x="4937760" y="3154680"/>
+            <a:ext cx="3383280" cy="320040"/>
+          </a:xfrm>
+          <a:prstGeom prst="rect">
+            <a:avLst/>
+          </a:prstGeom>
+          <a:noFill/>
+          <a:ln/>
+        </p:spPr>
+        <p:txBody>
+          <a:bodyPr wrap="square" lIns="0" tIns="0" rIns="0" bIns="0" rtlCol="0" anchor="ctr"/>
+          <a:lstStyle/>
+          <a:p>
+            <a:pPr indent="0" marL="0">
+              <a:buNone/>
+            </a:pPr>
+            <a:r>
+              <a:rPr lang="en-US" sz="1600" b="1" dirty="0">
+                <a:solidFill>
+                  <a:srgbClr val="FFFFFF"/>
+                </a:solidFill>
+                <a:latin typeface="Arial" pitchFamily="34" charset="0"/>
+                <a:ea typeface="Arial" pitchFamily="34" charset="-122"/>
+                <a:cs typeface="Arial" pitchFamily="34" charset="-120"/>
+              </a:rPr>
+              <a:t>Sourab Reddy</a:t>
+            </a:r>
+            <a:endParaRPr lang="en-US" sz="1600" dirty="0"/>
+          </a:p>
+        </p:txBody>
+      </p:sp>
+      <p:sp>
+        <p:nvSpPr>
+          <p:cNvPr id="14" name="Text 12"/>
+          <p:cNvSpPr/>
+          <p:nvPr/>
+        </p:nvSpPr>
+        <p:spPr>
+          <a:xfrm>
+            <a:off x="4937760" y="3566160"/>
+            <a:ext cx="3383280" cy="274320"/>
+          </a:xfrm>
+          <a:prstGeom prst="rect">
+            <a:avLst/>
+          </a:prstGeom>
+          <a:noFill/>
+          <a:ln/>
+        </p:spPr>
+        <p:txBody>
+          <a:bodyPr wrap="square" lIns="0" tIns="0" rIns="0" bIns="0" rtlCol="0" anchor="ctr"/>
+          <a:lstStyle/>
+          <a:p>
+            <a:pPr indent="0" marL="0">
+              <a:buNone/>
+            </a:pPr>
+            <a:r>
+              <a:rPr lang="en-US" sz="1300" dirty="0">
+                <a:solidFill>
+                  <a:srgbClr val="A8C5FF"/>
+                </a:solidFill>
+                <a:latin typeface="Calibri" pitchFamily="34" charset="0"/>
+                <a:ea typeface="Calibri" pitchFamily="34" charset="-122"/>
+                <a:cs typeface="Calibri" pitchFamily="34" charset="-120"/>
+              </a:rPr>
+              <a:t>GitHub: SOURABREDDY394</a:t>
             </a:r>
             <a:endParaRPr lang="en-US" sz="1300" dirty="0"/>
+          </a:p>
+        </p:txBody>
+      </p:sp>
+      <p:sp>
+        <p:nvSpPr>
+          <p:cNvPr id="15" name="Text 13"/>
+          <p:cNvSpPr/>
+          <p:nvPr/>
+        </p:nvSpPr>
+        <p:spPr>
+          <a:xfrm>
+            <a:off x="4937760" y="3931920"/>
+            <a:ext cx="3383280" cy="320040"/>
+          </a:xfrm>
+          <a:prstGeom prst="rect">
+            <a:avLst/>
+          </a:prstGeom>
+          <a:noFill/>
+          <a:ln/>
+        </p:spPr>
+        <p:txBody>
+          <a:bodyPr wrap="square" lIns="0" tIns="0" rIns="0" bIns="0" rtlCol="0" anchor="ctr"/>
+          <a:lstStyle/>
+          <a:p>
+            <a:pPr indent="0" marL="0">
+              <a:buNone/>
+            </a:pPr>
+            <a:r>
+              <a:rPr lang="en-US" sz="1200" dirty="0">
+                <a:solidFill>
+                  <a:srgbClr val="94A3B8"/>
+                </a:solidFill>
+                <a:latin typeface="Calibri" pitchFamily="34" charset="0"/>
+                <a:ea typeface="Calibri" pitchFamily="34" charset="-122"/>
+                <a:cs typeface="Calibri" pitchFamily="34" charset="-120"/>
+              </a:rPr>
+              <a:t>sourabreddimalla@gmail.com</a:t>
+            </a:r>
+            <a:endParaRPr lang="en-US" sz="1200" dirty="0"/>
           </a:p>
         </p:txBody>
       </p:sp>

</xml_diff>